<commit_message>
## AI-kapittelrekkefølge byttet - Verktøy er nå kapittel 2 (steg 19) og Agenter kapittel 3 (steg 20) i `/app/app/bergen-urban/page.js` - TOC-menyen og payoff-rekkefølgen oppdatert («Bygget av AI · Drevet av AI · Overvåket av AI» speiler kolonnene) - Screenshot-verifisert begge steg + PPTX/PDF-backup regenerert i synk - Next Action Items:   - **Presenter-visning**: La et eget vindu vise talenotater, neste slide og timer mens publikum ser decket   - **Demo-hånd**: Legg en diskré markør som beveger seg og klikker i portal-mockupen så den føles live   - **Kontinuitetsanker**: La DigiHome-ikonet gli fysisk mellom scenene som en rød tråd gjennom hele decket   - **Saks-dashboard**: Gi portalen et innsiktspanel med gjennomstrømming, forfalte saker og arbeidsmengde per person
</commit_message>
<xml_diff>
--- a/public/digihome-presentasjon-backup.pptx
+++ b/public/digihome-presentasjon-backup.pptx
@@ -3615,7 +3615,7 @@
       <p:grpSpPr/>
       <p:pic>
         <p:nvPicPr>
-          <p:cNvPr id="2" name="Picture 1" descr="20-ai-agenter.jpg"/>
+          <p:cNvPr id="2" name="Picture 1" descr="20-ai-verktoy.jpg"/>
           <p:cNvPicPr>
             <a:picLocks noChangeAspect="1"/>
           </p:cNvPicPr>
@@ -3657,7 +3657,7 @@
       <p:grpSpPr/>
       <p:pic>
         <p:nvPicPr>
-          <p:cNvPr id="2" name="Picture 1" descr="21-ai-verktoy.jpg"/>
+          <p:cNvPr id="2" name="Picture 1" descr="21-ai-agenter.jpg"/>
           <p:cNvPicPr>
             <a:picLocks noChangeAspect="1"/>
           </p:cNvPicPr>

</xml_diff>

<commit_message>
## Raskere agent-scene + slides midlertidig skjult - Vibe coding-scenen ~40 % raskere (71 % fremdrift etter 4,5 s mot før 53 %); deploy/reveal-tempo uendret - Kostnaden (steg 15/16) og Påstanden (steg 17) midlertidig skjult via ett `SKJULTE_STEG`-sett: navigasjon hopper over, TOC filtrerer dem bort, og 6-åring-sliden viser sitatet rent uten bakgrunnspåstanden — reverseres på ett sted - Verifisert med screenshots begge veier + PPTX/PDF-backup regenerert (19 slides) - Next Action Items:   - **Slides tilbake**: La meg reaktivere Kostnaden og Påstanden igjen når presentasjonen er over   - **Presenter-visning**: La et eget vindu vise talenotater, neste slide og timer mens publikum ser decket   - **Demo-hånd**: Legg en diskré markør som beveger seg og klikker i portal-mockupen så den føles live   - **Saks-dashboard**: Gi portalen et innsiktspanel med gjennomstrømming, forfalte saker og arbeidsmengde per person
</commit_message>
<xml_diff>
--- a/public/digihome-presentasjon-backup.pptx
+++ b/public/digihome-presentasjon-backup.pptx
@@ -24,9 +24,6 @@
     <p:sldId id="272" r:id="rId23"/>
     <p:sldId id="273" r:id="rId24"/>
     <p:sldId id="274" r:id="rId25"/>
-    <p:sldId id="275" r:id="rId26"/>
-    <p:sldId id="276" r:id="rId27"/>
-    <p:sldId id="277" r:id="rId28"/>
   </p:sldIdLst>
   <p:sldSz cx="12191695" cy="6858000" type="screen4x3"/>
   <p:notesSz cx="6858000" cy="9144000"/>
@@ -3405,7 +3402,7 @@
       <p:grpSpPr/>
       <p:pic>
         <p:nvPicPr>
-          <p:cNvPr id="2" name="Picture 1" descr="16-kostnad-tittel.jpg"/>
+          <p:cNvPr id="2" name="Picture 1" descr="19-seksaaringen.jpg"/>
           <p:cNvPicPr>
             <a:picLocks noChangeAspect="1"/>
           </p:cNvPicPr>
@@ -3447,7 +3444,7 @@
       <p:grpSpPr/>
       <p:pic>
         <p:nvPicPr>
-          <p:cNvPr id="2" name="Picture 1" descr="17-kostnad-tall.jpg"/>
+          <p:cNvPr id="2" name="Picture 1" descr="20-ai-verktoy.jpg"/>
           <p:cNvPicPr>
             <a:picLocks noChangeAspect="1"/>
           </p:cNvPicPr>
@@ -3489,7 +3486,7 @@
       <p:grpSpPr/>
       <p:pic>
         <p:nvPicPr>
-          <p:cNvPr id="2" name="Picture 1" descr="18-paastanden.jpg"/>
+          <p:cNvPr id="2" name="Picture 1" descr="21-ai-agenter.jpg"/>
           <p:cNvPicPr>
             <a:picLocks noChangeAspect="1"/>
           </p:cNvPicPr>
@@ -3531,7 +3528,7 @@
       <p:grpSpPr/>
       <p:pic>
         <p:nvPicPr>
-          <p:cNvPr id="2" name="Picture 1" descr="19-seksaaringen.jpg"/>
+          <p:cNvPr id="2" name="Picture 1" descr="22-book-mote.jpg"/>
           <p:cNvPicPr>
             <a:picLocks noChangeAspect="1"/>
           </p:cNvPicPr>
@@ -3574,132 +3571,6 @@
       <p:pic>
         <p:nvPicPr>
           <p:cNvPr id="2" name="Picture 1" descr="02-martin.jpg"/>
-          <p:cNvPicPr>
-            <a:picLocks noChangeAspect="1"/>
-          </p:cNvPicPr>
-          <p:nvPr/>
-        </p:nvPicPr>
-        <p:blipFill>
-          <a:blip r:embed="rId2"/>
-          <a:stretch>
-            <a:fillRect/>
-          </a:stretch>
-        </p:blipFill>
-        <p:spPr>
-          <a:xfrm>
-            <a:off x="0" y="0"/>
-            <a:ext cx="12191695" cy="6858000"/>
-          </a:xfrm>
-          <a:prstGeom prst="rect">
-            <a:avLst/>
-          </a:prstGeom>
-        </p:spPr>
-      </p:pic>
-    </p:spTree>
-  </p:cSld>
-  <p:clrMapOvr>
-    <a:masterClrMapping/>
-  </p:clrMapOvr>
-</p:sld>
-</file>
-
-<file path=ppt/slides/slide20.xml><?xml version="1.0" encoding="utf-8"?>
-<p:sld xmlns:a="http://schemas.openxmlformats.org/drawingml/2006/main" xmlns:p="http://schemas.openxmlformats.org/presentationml/2006/main" xmlns:r="http://schemas.openxmlformats.org/officeDocument/2006/relationships">
-  <p:cSld>
-    <p:spTree>
-      <p:nvGrpSpPr>
-        <p:cNvPr id="1" name=""/>
-        <p:cNvGrpSpPr/>
-        <p:nvPr/>
-      </p:nvGrpSpPr>
-      <p:grpSpPr/>
-      <p:pic>
-        <p:nvPicPr>
-          <p:cNvPr id="2" name="Picture 1" descr="20-ai-verktoy.jpg"/>
-          <p:cNvPicPr>
-            <a:picLocks noChangeAspect="1"/>
-          </p:cNvPicPr>
-          <p:nvPr/>
-        </p:nvPicPr>
-        <p:blipFill>
-          <a:blip r:embed="rId2"/>
-          <a:stretch>
-            <a:fillRect/>
-          </a:stretch>
-        </p:blipFill>
-        <p:spPr>
-          <a:xfrm>
-            <a:off x="0" y="0"/>
-            <a:ext cx="12191695" cy="6858000"/>
-          </a:xfrm>
-          <a:prstGeom prst="rect">
-            <a:avLst/>
-          </a:prstGeom>
-        </p:spPr>
-      </p:pic>
-    </p:spTree>
-  </p:cSld>
-  <p:clrMapOvr>
-    <a:masterClrMapping/>
-  </p:clrMapOvr>
-</p:sld>
-</file>
-
-<file path=ppt/slides/slide21.xml><?xml version="1.0" encoding="utf-8"?>
-<p:sld xmlns:a="http://schemas.openxmlformats.org/drawingml/2006/main" xmlns:p="http://schemas.openxmlformats.org/presentationml/2006/main" xmlns:r="http://schemas.openxmlformats.org/officeDocument/2006/relationships">
-  <p:cSld>
-    <p:spTree>
-      <p:nvGrpSpPr>
-        <p:cNvPr id="1" name=""/>
-        <p:cNvGrpSpPr/>
-        <p:nvPr/>
-      </p:nvGrpSpPr>
-      <p:grpSpPr/>
-      <p:pic>
-        <p:nvPicPr>
-          <p:cNvPr id="2" name="Picture 1" descr="21-ai-agenter.jpg"/>
-          <p:cNvPicPr>
-            <a:picLocks noChangeAspect="1"/>
-          </p:cNvPicPr>
-          <p:nvPr/>
-        </p:nvPicPr>
-        <p:blipFill>
-          <a:blip r:embed="rId2"/>
-          <a:stretch>
-            <a:fillRect/>
-          </a:stretch>
-        </p:blipFill>
-        <p:spPr>
-          <a:xfrm>
-            <a:off x="0" y="0"/>
-            <a:ext cx="12191695" cy="6858000"/>
-          </a:xfrm>
-          <a:prstGeom prst="rect">
-            <a:avLst/>
-          </a:prstGeom>
-        </p:spPr>
-      </p:pic>
-    </p:spTree>
-  </p:cSld>
-  <p:clrMapOvr>
-    <a:masterClrMapping/>
-  </p:clrMapOvr>
-</p:sld>
-</file>
-
-<file path=ppt/slides/slide22.xml><?xml version="1.0" encoding="utf-8"?>
-<p:sld xmlns:a="http://schemas.openxmlformats.org/drawingml/2006/main" xmlns:p="http://schemas.openxmlformats.org/presentationml/2006/main" xmlns:r="http://schemas.openxmlformats.org/officeDocument/2006/relationships">
-  <p:cSld>
-    <p:spTree>
-      <p:nvGrpSpPr>
-        <p:cNvPr id="1" name=""/>
-        <p:cNvGrpSpPr/>
-        <p:nvPr/>
-      </p:nvGrpSpPr>
-      <p:grpSpPr/>
-      <p:pic>
-        <p:nvPicPr>
-          <p:cNvPr id="2" name="Picture 1" descr="22-book-mote.jpg"/>
           <p:cNvPicPr>
             <a:picLocks noChangeAspect="1"/>
           </p:cNvPicPr>

</xml_diff>

<commit_message>
## «6-åringen» også skjult - Hele påstand-seksjonen (steg 17 + 18) og Kostnaden (15/16) er nå midlertidig skjult via SKJULTE_STEG-settet - Flyt verifisert: Integrasjonene → AI-måte 2 · Verktøy direkte, begge navigasjonsretninger + TOC (17 oppføringer) - PPTX/PDF-backup regenerert (18 slides) — alt reaktiveres på ett sted når ønskelig - Next Action Items:   - **Slides tilbake**: La meg reaktivere Kostnaden, Påstanden og 6-åringen igjen etter presentasjonen   - **Presenter-visning**: La et eget vindu vise talenotater, neste slide og timer mens publikum ser decket   - **Demo-hånd**: Legg en diskré markør som beveger seg og klikker i portal-mockupen så den føles live   - **Saks-dashboard**: Gi portalen et innsiktspanel med gjennomstrømming, forfalte saker og arbeidsmengde per person
</commit_message>
<xml_diff>
--- a/public/digihome-presentasjon-backup.pptx
+++ b/public/digihome-presentasjon-backup.pptx
@@ -23,7 +23,6 @@
     <p:sldId id="271" r:id="rId22"/>
     <p:sldId id="272" r:id="rId23"/>
     <p:sldId id="273" r:id="rId24"/>
-    <p:sldId id="274" r:id="rId25"/>
   </p:sldIdLst>
   <p:sldSz cx="12191695" cy="6858000" type="screen4x3"/>
   <p:notesSz cx="6858000" cy="9144000"/>
@@ -3402,7 +3401,7 @@
       <p:grpSpPr/>
       <p:pic>
         <p:nvPicPr>
-          <p:cNvPr id="2" name="Picture 1" descr="19-seksaaringen.jpg"/>
+          <p:cNvPr id="2" name="Picture 1" descr="20-ai-verktoy.jpg"/>
           <p:cNvPicPr>
             <a:picLocks noChangeAspect="1"/>
           </p:cNvPicPr>
@@ -3444,7 +3443,7 @@
       <p:grpSpPr/>
       <p:pic>
         <p:nvPicPr>
-          <p:cNvPr id="2" name="Picture 1" descr="20-ai-verktoy.jpg"/>
+          <p:cNvPr id="2" name="Picture 1" descr="21-ai-agenter.jpg"/>
           <p:cNvPicPr>
             <a:picLocks noChangeAspect="1"/>
           </p:cNvPicPr>
@@ -3475,48 +3474,6 @@
 </file>
 
 <file path=ppt/slides/slide18.xml><?xml version="1.0" encoding="utf-8"?>
-<p:sld xmlns:a="http://schemas.openxmlformats.org/drawingml/2006/main" xmlns:p="http://schemas.openxmlformats.org/presentationml/2006/main" xmlns:r="http://schemas.openxmlformats.org/officeDocument/2006/relationships">
-  <p:cSld>
-    <p:spTree>
-      <p:nvGrpSpPr>
-        <p:cNvPr id="1" name=""/>
-        <p:cNvGrpSpPr/>
-        <p:nvPr/>
-      </p:nvGrpSpPr>
-      <p:grpSpPr/>
-      <p:pic>
-        <p:nvPicPr>
-          <p:cNvPr id="2" name="Picture 1" descr="21-ai-agenter.jpg"/>
-          <p:cNvPicPr>
-            <a:picLocks noChangeAspect="1"/>
-          </p:cNvPicPr>
-          <p:nvPr/>
-        </p:nvPicPr>
-        <p:blipFill>
-          <a:blip r:embed="rId2"/>
-          <a:stretch>
-            <a:fillRect/>
-          </a:stretch>
-        </p:blipFill>
-        <p:spPr>
-          <a:xfrm>
-            <a:off x="0" y="0"/>
-            <a:ext cx="12191695" cy="6858000"/>
-          </a:xfrm>
-          <a:prstGeom prst="rect">
-            <a:avLst/>
-          </a:prstGeom>
-        </p:spPr>
-      </p:pic>
-    </p:spTree>
-  </p:cSld>
-  <p:clrMapOvr>
-    <a:masterClrMapping/>
-  </p:clrMapOvr>
-</p:sld>
-</file>
-
-<file path=ppt/slides/slide19.xml><?xml version="1.0" encoding="utf-8"?>
 <p:sld xmlns:a="http://schemas.openxmlformats.org/drawingml/2006/main" xmlns:p="http://schemas.openxmlformats.org/presentationml/2006/main" xmlns:r="http://schemas.openxmlformats.org/officeDocument/2006/relationships">
   <p:cSld>
     <p:spTree>

</xml_diff>

<commit_message>
## AI-kapitler samlet + slutt-slides fjernet - Alle tre kapitler (Utvikling, Verktøy, Agenter) avsløres nå samlet på steg 7 med stagger + payoff til slutt; screenshot-verifisert tidlig/sen beat - Steg 19/20 lagt i SKJULTE_STEG (Integrasjonene → rett til Book et møte, verifisert); TOC oppdatert («AI i alle lag», 15 oppføringer) - PPTX/PDF-backup regenerert (16 slides) og lastet opp til objektlagring; KREVER REDEPLOY sammen med GPU-fiksen - Next Action Items:   - **Slides tilbake**: La meg reaktivere de skjulte slidene (Kostnaden, Påstanden, 6-åringen, AI-måte 2/3) etter presentasjonen   - **Samme GPU-kur**: Gi produktveggen og integrasjonsscenen samme window-mount og filterfrie hviletilstand for total trygghet   - **Presenter-visning**: La et eget vindu vise talenotater, neste slide og timer mens publikum ser decket   - **Saks-dashboard**: Gi portalen et innsiktspanel med gjennomstrømming, forfalte saker og arbeidsmengde per person
</commit_message>
<xml_diff>
--- a/public/digihome-presentasjon-backup.pptx
+++ b/public/digihome-presentasjon-backup.pptx
@@ -21,8 +21,6 @@
     <p:sldId id="269" r:id="rId20"/>
     <p:sldId id="270" r:id="rId21"/>
     <p:sldId id="271" r:id="rId22"/>
-    <p:sldId id="272" r:id="rId23"/>
-    <p:sldId id="273" r:id="rId24"/>
   </p:sldIdLst>
   <p:sldSz cx="12191695" cy="6858000" type="screen4x3"/>
   <p:notesSz cx="6858000" cy="9144000"/>
@@ -3401,90 +3399,6 @@
       <p:grpSpPr/>
       <p:pic>
         <p:nvPicPr>
-          <p:cNvPr id="2" name="Picture 1" descr="20-ai-verktoy.jpg"/>
-          <p:cNvPicPr>
-            <a:picLocks noChangeAspect="1"/>
-          </p:cNvPicPr>
-          <p:nvPr/>
-        </p:nvPicPr>
-        <p:blipFill>
-          <a:blip r:embed="rId2"/>
-          <a:stretch>
-            <a:fillRect/>
-          </a:stretch>
-        </p:blipFill>
-        <p:spPr>
-          <a:xfrm>
-            <a:off x="0" y="0"/>
-            <a:ext cx="12191695" cy="6858000"/>
-          </a:xfrm>
-          <a:prstGeom prst="rect">
-            <a:avLst/>
-          </a:prstGeom>
-        </p:spPr>
-      </p:pic>
-    </p:spTree>
-  </p:cSld>
-  <p:clrMapOvr>
-    <a:masterClrMapping/>
-  </p:clrMapOvr>
-</p:sld>
-</file>
-
-<file path=ppt/slides/slide17.xml><?xml version="1.0" encoding="utf-8"?>
-<p:sld xmlns:a="http://schemas.openxmlformats.org/drawingml/2006/main" xmlns:p="http://schemas.openxmlformats.org/presentationml/2006/main" xmlns:r="http://schemas.openxmlformats.org/officeDocument/2006/relationships">
-  <p:cSld>
-    <p:spTree>
-      <p:nvGrpSpPr>
-        <p:cNvPr id="1" name=""/>
-        <p:cNvGrpSpPr/>
-        <p:nvPr/>
-      </p:nvGrpSpPr>
-      <p:grpSpPr/>
-      <p:pic>
-        <p:nvPicPr>
-          <p:cNvPr id="2" name="Picture 1" descr="21-ai-agenter.jpg"/>
-          <p:cNvPicPr>
-            <a:picLocks noChangeAspect="1"/>
-          </p:cNvPicPr>
-          <p:nvPr/>
-        </p:nvPicPr>
-        <p:blipFill>
-          <a:blip r:embed="rId2"/>
-          <a:stretch>
-            <a:fillRect/>
-          </a:stretch>
-        </p:blipFill>
-        <p:spPr>
-          <a:xfrm>
-            <a:off x="0" y="0"/>
-            <a:ext cx="12191695" cy="6858000"/>
-          </a:xfrm>
-          <a:prstGeom prst="rect">
-            <a:avLst/>
-          </a:prstGeom>
-        </p:spPr>
-      </p:pic>
-    </p:spTree>
-  </p:cSld>
-  <p:clrMapOvr>
-    <a:masterClrMapping/>
-  </p:clrMapOvr>
-</p:sld>
-</file>
-
-<file path=ppt/slides/slide18.xml><?xml version="1.0" encoding="utf-8"?>
-<p:sld xmlns:a="http://schemas.openxmlformats.org/drawingml/2006/main" xmlns:p="http://schemas.openxmlformats.org/presentationml/2006/main" xmlns:r="http://schemas.openxmlformats.org/officeDocument/2006/relationships">
-  <p:cSld>
-    <p:spTree>
-      <p:nvGrpSpPr>
-        <p:cNvPr id="1" name=""/>
-        <p:cNvGrpSpPr/>
-        <p:nvPr/>
-      </p:nvGrpSpPr>
-      <p:grpSpPr/>
-      <p:pic>
-        <p:nvPicPr>
           <p:cNvPr id="2" name="Picture 1" descr="22-book-mote.jpg"/>
           <p:cNvPicPr>
             <a:picLocks noChangeAspect="1"/>
@@ -3779,7 +3693,7 @@
       <p:grpSpPr/>
       <p:pic>
         <p:nvPicPr>
-          <p:cNvPr id="2" name="Picture 1" descr="08-ai-utvikling.jpg"/>
+          <p:cNvPr id="2" name="Picture 1" descr="08-ai-tre-mater.jpg"/>
           <p:cNvPicPr>
             <a:picLocks noChangeAspect="1"/>
           </p:cNvPicPr>

</xml_diff>